<commit_message>
Refresh editable presentation deliverable
</commit_message>
<xml_diff>
--- a/Submission/AirBorder-Deliverables/AirBorder-Presentation.pptx
+++ b/Submission/AirBorder-Deliverables/AirBorder-Presentation.pptx
@@ -2,25 +2,25 @@
 <file path=ppt/presentation.xml><?xml version="1.0" encoding="utf-8"?>
 <p:presentation xmlns:p="http://schemas.openxmlformats.org/presentationml/2006/main">
   <p:sldMasterIdLst>
-    <p:sldMasterId xmlns:r="http://schemas.openxmlformats.org/officeDocument/2006/relationships" id="2147483648" r:id="R24e0d148f25d4734"/>
+    <p:sldMasterId xmlns:r="http://schemas.openxmlformats.org/officeDocument/2006/relationships" id="2147483648" r:id="Rc3c9b52f029a4613"/>
   </p:sldMasterIdLst>
   <p:notesMasterIdLst>
-    <p:notesMasterId xmlns:r="http://schemas.openxmlformats.org/officeDocument/2006/relationships" r:id="R9cc12c2fcb064d76"/>
+    <p:notesMasterId xmlns:r="http://schemas.openxmlformats.org/officeDocument/2006/relationships" r:id="Rd42ff9bc68b64e4f"/>
   </p:notesMasterIdLst>
   <p:sldIdLst>
-    <p:sldId xmlns:r="http://schemas.openxmlformats.org/officeDocument/2006/relationships" id="256" r:id="R24631cdb8ce645b3"/>
-    <p:sldId xmlns:r="http://schemas.openxmlformats.org/officeDocument/2006/relationships" id="257" r:id="R6043038be91b4710"/>
-    <p:sldId xmlns:r="http://schemas.openxmlformats.org/officeDocument/2006/relationships" id="258" r:id="Raad3e8649752469a"/>
-    <p:sldId xmlns:r="http://schemas.openxmlformats.org/officeDocument/2006/relationships" id="259" r:id="Rcc7ffa9b564542c6"/>
-    <p:sldId xmlns:r="http://schemas.openxmlformats.org/officeDocument/2006/relationships" id="260" r:id="Rf94ce761140a4f81"/>
-    <p:sldId xmlns:r="http://schemas.openxmlformats.org/officeDocument/2006/relationships" id="261" r:id="R792d478af6664320"/>
-    <p:sldId xmlns:r="http://schemas.openxmlformats.org/officeDocument/2006/relationships" id="262" r:id="Re6c7ea954483498b"/>
-    <p:sldId xmlns:r="http://schemas.openxmlformats.org/officeDocument/2006/relationships" id="263" r:id="Rb0e47a1a9ad44127"/>
-    <p:sldId xmlns:r="http://schemas.openxmlformats.org/officeDocument/2006/relationships" id="264" r:id="R5287548243df4c91"/>
-    <p:sldId xmlns:r="http://schemas.openxmlformats.org/officeDocument/2006/relationships" id="265" r:id="R6b2e9b6d24de4165"/>
-    <p:sldId xmlns:r="http://schemas.openxmlformats.org/officeDocument/2006/relationships" id="266" r:id="R1147c56c81f64b34"/>
-    <p:sldId xmlns:r="http://schemas.openxmlformats.org/officeDocument/2006/relationships" id="267" r:id="Ra421b4b81b7c44fa"/>
-    <p:sldId xmlns:r="http://schemas.openxmlformats.org/officeDocument/2006/relationships" id="268" r:id="R91eac9cf350e419a"/>
+    <p:sldId xmlns:r="http://schemas.openxmlformats.org/officeDocument/2006/relationships" id="256" r:id="R09d4ffdef71349b6"/>
+    <p:sldId xmlns:r="http://schemas.openxmlformats.org/officeDocument/2006/relationships" id="257" r:id="R1982a3febeef47ae"/>
+    <p:sldId xmlns:r="http://schemas.openxmlformats.org/officeDocument/2006/relationships" id="258" r:id="R79dbbc1c70484304"/>
+    <p:sldId xmlns:r="http://schemas.openxmlformats.org/officeDocument/2006/relationships" id="259" r:id="R3b414b4c58ac4564"/>
+    <p:sldId xmlns:r="http://schemas.openxmlformats.org/officeDocument/2006/relationships" id="260" r:id="R487df2c7bdec4053"/>
+    <p:sldId xmlns:r="http://schemas.openxmlformats.org/officeDocument/2006/relationships" id="261" r:id="Reb1f989cfed948b9"/>
+    <p:sldId xmlns:r="http://schemas.openxmlformats.org/officeDocument/2006/relationships" id="262" r:id="Rf1c6e8c25c1b4df6"/>
+    <p:sldId xmlns:r="http://schemas.openxmlformats.org/officeDocument/2006/relationships" id="263" r:id="R18264f8c1f464bca"/>
+    <p:sldId xmlns:r="http://schemas.openxmlformats.org/officeDocument/2006/relationships" id="264" r:id="R79cb54a61fc14b54"/>
+    <p:sldId xmlns:r="http://schemas.openxmlformats.org/officeDocument/2006/relationships" id="265" r:id="Red31e0e909d54ae0"/>
+    <p:sldId xmlns:r="http://schemas.openxmlformats.org/officeDocument/2006/relationships" id="266" r:id="R20a059a0d094459d"/>
+    <p:sldId xmlns:r="http://schemas.openxmlformats.org/officeDocument/2006/relationships" id="267" r:id="R4efa12bd7725485a"/>
+    <p:sldId xmlns:r="http://schemas.openxmlformats.org/officeDocument/2006/relationships" id="268" r:id="R2b2964b93c8f427b"/>
   </p:sldIdLst>
   <p:sldSz cx="12192000" cy="6858000"/>
   <p:notesSz cx="6858000" cy="9144000"/>
@@ -1310,7 +1310,7 @@
   </p:cSld>
   <p:clrMap bg1="lt1" tx1="dk1" bg2="lt2" tx2="dk2" accent1="accent1" accent2="accent2" accent3="accent3" accent4="accent4" accent5="accent5" accent6="accent6" hlink="hlink" folHlink="folHlink"/>
   <p:sldLayoutIdLst>
-    <p:sldLayoutId xmlns:r="http://schemas.openxmlformats.org/officeDocument/2006/relationships" id="2147483649" r:id="R8ea35bb693b94396"/>
+    <p:sldLayoutId xmlns:r="http://schemas.openxmlformats.org/officeDocument/2006/relationships" id="2147483649" r:id="R31e54626425c44d0"/>
   </p:sldLayoutIdLst>
   <p:txStyles>
     <p:titleStyle>
@@ -3240,7 +3240,7 @@
                   <a:srgbClr val="111827"/>
                 </a:solidFill>
               </a:rPr>
-              <a:t>Architecture combines ticket parsing, airport data, and guidance</a:t>
+              <a:t>Algorithms turn ticket facts into a connection plan</a:t>
             </a:r>
           </a:p>
         </p:txBody>
@@ -3443,7 +3443,7 @@
                   <a:srgbClr val="5B6472"/>
                 </a:solidFill>
               </a:rPr>
-              <a:t>Multi-leg flights, airport changes, transfer type, and baggage direction</a:t>
+              <a:t>Route, airport changes, transfer type, baggage direction, and boarding deadline</a:t>
             </a:r>
           </a:p>
         </p:txBody>
@@ -3613,7 +3613,7 @@
                   <a:srgbClr val="5B6472"/>
                 </a:solidFill>
               </a:rPr>
-              <a:t>Nationality, documents, budget, fatigue, accessibility</a:t>
+              <a:t>Walking preference, accessibility needs, budget, and traveller time buffer</a:t>
             </a:r>
           </a:p>
         </p:txBody>
@@ -3783,7 +3783,7 @@
                   <a:srgbClr val="5B6472"/>
                 </a:solidFill>
               </a:rPr>
-              <a:t>Airport lookup, local search, maps, city transfer routes, weather, and places</a:t>
+              <a:t>AirportDirectory, MapKit search, time-dependent routes, weather, and places</a:t>
             </a:r>
           </a:p>
         </p:txBody>
@@ -3953,7 +3953,7 @@
                   <a:srgbClr val="5B6472"/>
                 </a:solidFill>
               </a:rPr>
-              <a:t>Saved tickets, offline fixtures, and personal preferences</a:t>
+              <a:t>Saved tickets, offline fixtures, personal preferences, and timing observations</a:t>
             </a:r>
           </a:p>
         </p:txBody>
@@ -4039,7 +4039,7 @@
                   <a:srgbClr val="111827"/>
                 </a:solidFill>
               </a:rPr>
-              <a:t>Build context</a:t>
+              <a:t>Parse ticket</a:t>
             </a:r>
           </a:p>
         </p:txBody>
@@ -4155,7 +4155,7 @@
                   <a:srgbClr val="111827"/>
                 </a:solidFill>
               </a:rPr>
-              <a:t>Compare plans</a:t>
+              <a:t>Estimate time</a:t>
             </a:r>
           </a:p>
         </p:txBody>
@@ -4271,7 +4271,7 @@
                   <a:srgbClr val="111827"/>
                 </a:solidFill>
               </a:rPr>
-              <a:t>Route user</a:t>
+              <a:t>Rank routes</a:t>
             </a:r>
           </a:p>
         </p:txBody>
@@ -4387,7 +4387,7 @@
                   <a:srgbClr val="111827"/>
                 </a:solidFill>
               </a:rPr>
-              <a:t>Notify changes</a:t>
+              <a:t>Update plan</a:t>
             </a:r>
           </a:p>
         </p:txBody>
@@ -4438,7 +4438,7 @@
                   <a:srgbClr val="111827"/>
                 </a:solidFill>
               </a:rPr>
-              <a:t>AirportDirectory resolves known airports from the bundled registry and expands coverage with MapKit search, so ticket-driven guidance can adapt beyond the Japan demo route.</a:t>
+              <a:t>Connection slack: S = T(board) − [T(transfer) + T(bags) + T(entry) + T(security) + T(walk) + buffer]. A plan is feasible when S ≥ 0; route ranking minimises time, transfers, walking, and disruption.</a:t>
             </a:r>
           </a:p>
         </p:txBody>
@@ -4569,7 +4569,7 @@
                   <a:srgbClr val="111827"/>
                 </a:solidFill>
               </a:rPr>
-              <a:t>Build, demo, and validation are ready for review</a:t>
+              <a:t>Validation and research pathway</a:t>
             </a:r>
           </a:p>
         </p:txBody>
@@ -4651,7 +4651,7 @@
           <p:nvPr/>
         </p:nvPicPr>
         <p:blipFill>
-          <a:blip xmlns:r="http://schemas.openxmlformats.org/officeDocument/2006/relationships" xmlns:a="http://schemas.openxmlformats.org/drawingml/2006/main" r:embed="R47f70677803748b9"/>
+          <a:blip xmlns:r="http://schemas.openxmlformats.org/officeDocument/2006/relationships" xmlns:a="http://schemas.openxmlformats.org/drawingml/2006/main" r:embed="R256ac9b1774d4c70"/>
           <a:stretch xmlns:a="http://schemas.openxmlformats.org/drawingml/2006/main"/>
         </p:blipFill>
         <p:spPr>
@@ -4831,7 +4831,7 @@
                   <a:srgbClr val="5B6472"/>
                 </a:solidFill>
               </a:rPr>
-              <a:t>Simulator walkthrough · sample ticket import · AR preview · city map</a:t>
+              <a:t>Ticket fixture · Simulator walkthrough · AR preview · city map</a:t>
             </a:r>
           </a:p>
         </p:txBody>
@@ -5001,7 +5001,7 @@
                   <a:srgbClr val="5B6472"/>
                 </a:solidFill>
               </a:rPr>
-              <a:t>106 automated tests passed. The ticket fixture verifies BKK → HND → NRT → LAX, baggage handling, and airport-transfer behavior.</a:t>
+              <a:t>106 automated tests passed. The fixture verifies BKK → HND → NRT → LAX, ticket-derived baggage handling, and airport-transfer behaviour.</a:t>
             </a:r>
           </a:p>
         </p:txBody>
@@ -5171,7 +5171,7 @@
                   <a:srgbClr val="5B6472"/>
                 </a:solidFill>
               </a:rPr>
-              <a:t>Use the GitHub build guide to run in Simulator or on a personal iPhone. Future work: live provider credentials, indoor map partnerships, and on-device AR testing.</a:t>
+              <a:t>Research next: model transfer components as probability distributions, estimate P(on time), calibrate against observed journeys, and optimise reliability, walking, cost, and accessibility together.</a:t>
             </a:r>
           </a:p>
         </p:txBody>
@@ -10348,7 +10348,7 @@
           <p:nvPr/>
         </p:nvPicPr>
         <p:blipFill>
-          <a:blip xmlns:r="http://schemas.openxmlformats.org/officeDocument/2006/relationships" xmlns:a="http://schemas.openxmlformats.org/drawingml/2006/main" r:embed="R78b6e50f441c4b58"/>
+          <a:blip xmlns:r="http://schemas.openxmlformats.org/officeDocument/2006/relationships" xmlns:a="http://schemas.openxmlformats.org/drawingml/2006/main" r:embed="Re7de118628d84af7"/>
           <a:stretch xmlns:a="http://schemas.openxmlformats.org/drawingml/2006/main"/>
         </p:blipFill>
         <p:spPr>
@@ -10817,7 +10817,7 @@
           <p:nvPr/>
         </p:nvPicPr>
         <p:blipFill>
-          <a:blip xmlns:r="http://schemas.openxmlformats.org/officeDocument/2006/relationships" xmlns:a="http://schemas.openxmlformats.org/drawingml/2006/main" r:embed="R12978ad7f7174ce3"/>
+          <a:blip xmlns:r="http://schemas.openxmlformats.org/officeDocument/2006/relationships" xmlns:a="http://schemas.openxmlformats.org/drawingml/2006/main" r:embed="Rf358b9fd2f60434c"/>
           <a:stretch xmlns:a="http://schemas.openxmlformats.org/drawingml/2006/main"/>
         </p:blipFill>
         <p:spPr>

</xml_diff>